<commit_message>
Update the final report and presentation to the final version
</commit_message>
<xml_diff>
--- a/thesis/PPSI_Final_Presentation.pptx
+++ b/thesis/PPSI_Final_Presentation.pptx
@@ -6368,7 +6368,7 @@
                 </a:solidFill>
                 <a:latin typeface="Calibri"/>
               </a:rPr>
-              <a:t> FL − PRE: −0.000508 → federation adds nothing over a strong pretrain</a:t>
+              <a:t> FL − PRE: −0.000508 [−0.000933, −0.000037]: slightly worse than the pretrain alone</a:t>
             </a:r>
           </a:p>
           <a:p>
@@ -8815,7 +8815,7 @@
                 </a:solidFill>
                 <a:latin typeface="Calibri"/>
               </a:rPr>
-              <a:t>Warm inference ≈ 1.7–3 ms per recommendation</a:t>
+              <a:t>Warm median latency 1.7–5.1 ms per query</a:t>
             </a:r>
           </a:p>
           <a:p>
@@ -12125,7 +12125,7 @@
         <p:spPr>
           <a:xfrm>
             <a:off x="4617720" y="2331720"/>
-            <a:ext cx="1600200" cy="1097280"/>
+            <a:ext cx="1600200" cy="1554480"/>
           </a:xfrm>
           <a:prstGeom prst="rect">
             <a:avLst/>
@@ -12184,7 +12184,7 @@
         <p:spPr>
           <a:xfrm>
             <a:off x="10195560" y="2331720"/>
-            <a:ext cx="1600200" cy="1097280"/>
+            <a:ext cx="1600200" cy="1554480"/>
           </a:xfrm>
           <a:prstGeom prst="rect">
             <a:avLst/>
@@ -12243,7 +12243,7 @@
         <p:spPr>
           <a:xfrm>
             <a:off x="4617720" y="4846320"/>
-            <a:ext cx="1600200" cy="1097280"/>
+            <a:ext cx="1600200" cy="1554480"/>
           </a:xfrm>
           <a:prstGeom prst="rect">
             <a:avLst/>
@@ -12264,7 +12264,7 @@
                 </a:solidFill>
                 <a:latin typeface="Calibri"/>
               </a:rPr>
-              <a:t>Events per session: heavy-tailed, median 2</a:t>
+              <a:t>Events per session: median 2, long tail</a:t>
             </a:r>
           </a:p>
         </p:txBody>
@@ -12302,7 +12302,7 @@
         <p:spPr>
           <a:xfrm>
             <a:off x="10195560" y="4846320"/>
-            <a:ext cx="1600200" cy="1097280"/>
+            <a:ext cx="1600200" cy="1554480"/>
           </a:xfrm>
           <a:prstGeom prst="rect">
             <a:avLst/>

</xml_diff>